<commit_message>
chore: synchronize Aletis server improvements and preserve private data
</commit_message>
<xml_diff>
--- a/apps/api/src/services/processo-assessoria/templates/R.OP.006_Relatorio_Diagnostico_Financeiro.pptx
+++ b/apps/api/src/services/processo-assessoria/templates/R.OP.006_Relatorio_Diagnostico_Financeiro.pptx
@@ -6713,7 +6713,7 @@
                 <a:cs typeface="Montserrat Bold"/>
                 <a:sym typeface="Montserrat Bold"/>
               </a:rPr>
-              <a:t>TEX CAPITAL, a </a:t>
+              <a:t>ALETIS, a </a:t>
             </a:r>
             <a:r>
               <a:rPr lang="en-US" sz="4800" b="1" dirty="0" err="1">
@@ -6847,7 +6847,7 @@
                 <a:cs typeface="Montserrat"/>
                 <a:sym typeface="Montserrat"/>
               </a:rPr>
-              <a:t>A TEX CAPITAL é </a:t>
+              <a:t>A ALETIS é </a:t>
             </a:r>
             <a:r>
               <a:rPr lang="en-US" sz="2399" dirty="0" err="1">

</xml_diff>